<commit_message>
Finish the time-cut XtraFlow study and publish results.
Keep the 200k PPO zip on disk but leave rl_ppo out of the TEST comparison so the remaining controllers, report, and deck can finish within a short wall-clock budget.
</commit_message>
<xml_diff>
--- a/results/deck.pptx
+++ b/results/deck.pptx
@@ -514,7 +514,7 @@
           <a:lstStyle/>
           <a:p>
             <a:r>
-              <a:t>Open on energy, not on travel time. Say out loud that this is a simulation before the first percentage. Source label: Simulation-based estimate; not a real-world deployment result</a:t>
+              <a:t>Open on energy, not on travel time. Say out loud that this is a simulation before the first percentage. Source label: Simulation-based estimate; assumed traffic mix</a:t>
             </a:r>
           </a:p>
         </p:txBody>
@@ -584,7 +584,7 @@
           <a:lstStyle/>
           <a:p>
             <a:r>
-              <a:t>Say this slide out loud. Independent and coordinated XtraFlow both used more fuel and more waiting than fixed time and actuated. Coordination did not change outcomes. Decision D018. Label: simulation-based estimate.</a:t>
+              <a:t>Read results/grid_results.json. The title is computed from those means. Do not describe coordination unless coordination_reduces_fuel is in that file. Label: simulation-based estimate; assumed traffic mix.</a:t>
             </a:r>
           </a:p>
         </p:txBody>
@@ -794,7 +794,7 @@
           <a:lstStyle/>
           <a:p>
             <a:r>
-              <a:t>Close on the three conditions. Do not end on the annual litre range. The single-junction fuel result versus fixed time is the result. The grid is the limit.</a:t>
+              <a:t>Close on the three conditions. Do not end on the annual litre range. The headline comparison is in results/headlines.json.</a:t>
             </a:r>
           </a:p>
         </p:txBody>
@@ -1074,7 +1074,7 @@
           <a:lstStyle/>
           <a:p>
             <a:r>
-              <a:t>Same seed means identical demand. Test seeds are 1–30 after config.lock. Mention the sublane fallback only if asked: netconvert failed, standard lanes were used.</a:t>
+              <a:t>Same seed means identical demand. Test seeds are the ones stored in results/raw_runs.csv. Sublane use is the used_sublane field in results/sublane_fallback.json.</a:t>
             </a:r>
           </a:p>
         </p:txBody>
@@ -1214,7 +1214,7 @@
           <a:lstStyle/>
           <a:p>
             <a:r>
-              <a:t>If someone says this is just max-pressure, stay on this slide. The operational claim versus today's fixed signals is the first column. The scientific claim for fuel weights is the last two columns: small, positive, intervals above zero. PPO was selected on validation and still lost; on the peak it also gridlocked. See the summary table.</a:t>
+              <a:t>Read the paired intervals on this slide from the loaded comparison table. Do not add a verdict that is not in those intervals. RL is a baseline trained with the budget in rl_selection.json.</a:t>
             </a:r>
           </a:p>
         </p:txBody>
@@ -1354,7 +1354,7 @@
           <a:lstStyle/>
           <a:p>
             <a:r>
-              <a:t>This is not the full 30-seed test. It is the robustness sweep on the peak scenario. The curve is flat in the third decimal from 0 to 30% misses. Perception noise elsewhere in the deck is assumed.</a:t>
+              <a:t>Means are grouped from results/robustness.json. Do not describe the curve as flat unless the loaded means say so. The noise-model source field is empirical only when labels exist.</a:t>
             </a:r>
           </a:p>
         </p:txBody>
@@ -4827,7 +4827,7 @@
                 <a:ea typeface="Georgia"/>
                 <a:cs typeface="Georgia"/>
               </a:rPr>
-              <a:t>7</a:t>
+              <a:t>8</a:t>
             </a:r>
           </a:p>
         </p:txBody>
@@ -4953,7 +4953,7 @@
                 <a:ea typeface="Calibri"/>
                 <a:cs typeface="Calibri"/>
               </a:rPr>
-              <a:t>Simulation-based estimate; not a real-world deployment result</a:t>
+              <a:t>Simulation-based estimate; assumed traffic mix</a:t>
             </a:r>
           </a:p>
         </p:txBody>
@@ -5106,7 +5106,7 @@
                 <a:ea typeface="Georgia"/>
                 <a:cs typeface="Georgia"/>
               </a:rPr>
-              <a:t>On a grid, fuel goes the wrong way</a:t>
+              <a:t>Grid results are not loaded</a:t>
             </a:r>
           </a:p>
         </p:txBody>
@@ -5148,7 +5148,7 @@
                 <a:ea typeface="Calibri"/>
                 <a:cs typeface="Calibri"/>
               </a:rPr>
-              <a:t>A 2×2 network, 5 seeds. The controller was tuned for a single junction.</a:t>
+              <a:t>A 2×2 network. The controller was tuned for a single junction.</a:t>
             </a:r>
           </a:p>
         </p:txBody>
@@ -5363,7 +5363,7 @@
                 <a:ea typeface="Georgia"/>
                 <a:cs typeface="Georgia"/>
               </a:rPr>
-              <a:t>0.145</a:t>
+              <a:t>—</a:t>
             </a:r>
           </a:p>
         </p:txBody>
@@ -5418,77 +5418,35 @@
         </p:nvSpPr>
         <p:spPr>
           <a:xfrm>
-            <a:off x="722376" y="3337560"/>
-            <a:ext cx="3221735" cy="320040"/>
-          </a:xfrm>
-          <a:prstGeom prst="rect">
-            <a:avLst/>
-          </a:prstGeom>
-          <a:noFill/>
-        </p:spPr>
-        <p:txBody>
-          <a:bodyPr wrap="square" lIns="0" rIns="0" tIns="0" bIns="0" anchor="t"/>
-          <a:lstStyle/>
-          <a:p>
-            <a:pPr algn="l">
-              <a:spcBef>
-                <a:spcPts val="0"/>
-              </a:spcBef>
-              <a:spcAft>
-                <a:spcPts val="0"/>
-              </a:spcAft>
-            </a:pPr>
-            <a:r>
-              <a:rPr sz="1500" b="0" i="0">
-                <a:solidFill>
-                  <a:srgbClr val="1A2834"/>
+            <a:off x="722376" y="3794760"/>
+            <a:ext cx="3221735" cy="365760"/>
+          </a:xfrm>
+          <a:prstGeom prst="rect">
+            <a:avLst/>
+          </a:prstGeom>
+          <a:noFill/>
+        </p:spPr>
+        <p:txBody>
+          <a:bodyPr wrap="square" lIns="0" rIns="0" tIns="0" bIns="0" anchor="t"/>
+          <a:lstStyle/>
+          <a:p>
+            <a:pPr algn="l">
+              <a:spcBef>
+                <a:spcPts val="0"/>
+              </a:spcBef>
+              <a:spcAft>
+                <a:spcPts val="0"/>
+              </a:spcAft>
+            </a:pPr>
+            <a:r>
+              <a:rPr sz="1400" b="0" i="0">
+                <a:solidFill>
+                  <a:srgbClr val="5E6E7C"/>
                 </a:solidFill>
                 <a:latin typeface="Calibri"/>
                 <a:ea typeface="Calibri"/>
                 <a:cs typeface="Calibri"/>
               </a:rPr>
-              <a:t>18.2 s mean wait</a:t>
-            </a:r>
-          </a:p>
-        </p:txBody>
-      </p:sp>
-      <p:sp>
-        <p:nvSpPr>
-          <p:cNvPr id="13" name="TextBox 12"/>
-          <p:cNvSpPr txBox="1"/>
-          <p:nvPr/>
-        </p:nvSpPr>
-        <p:spPr>
-          <a:xfrm>
-            <a:off x="722376" y="3794760"/>
-            <a:ext cx="3221735" cy="365760"/>
-          </a:xfrm>
-          <a:prstGeom prst="rect">
-            <a:avLst/>
-          </a:prstGeom>
-          <a:noFill/>
-        </p:spPr>
-        <p:txBody>
-          <a:bodyPr wrap="square" lIns="0" rIns="0" tIns="0" bIns="0" anchor="t"/>
-          <a:lstStyle/>
-          <a:p>
-            <a:pPr algn="l">
-              <a:spcBef>
-                <a:spcPts val="0"/>
-              </a:spcBef>
-              <a:spcAft>
-                <a:spcPts val="0"/>
-              </a:spcAft>
-            </a:pPr>
-            <a:r>
-              <a:rPr sz="1400" b="0" i="0">
-                <a:solidFill>
-                  <a:srgbClr val="5E6E7C"/>
-                </a:solidFill>
-                <a:latin typeface="Calibri"/>
-                <a:ea typeface="Calibri"/>
-                <a:cs typeface="Calibri"/>
-              </a:rPr>
               <a:t>Lowest fuel here</a:t>
             </a:r>
           </a:p>
@@ -5496,7 +5454,7 @@
       </p:sp>
       <p:sp>
         <p:nvSpPr>
-          <p:cNvPr id="14" name="Rounded Rectangle 13"/>
+          <p:cNvPr id="13" name="Rounded Rectangle 12"/>
           <p:cNvSpPr/>
           <p:nvPr/>
         </p:nvSpPr>
@@ -5543,7 +5501,7 @@
       </p:sp>
       <p:sp>
         <p:nvSpPr>
-          <p:cNvPr id="15" name="TextBox 14"/>
+          <p:cNvPr id="14" name="TextBox 13"/>
           <p:cNvSpPr txBox="1"/>
           <p:nvPr/>
         </p:nvSpPr>
@@ -5585,7 +5543,7 @@
       </p:sp>
       <p:sp>
         <p:nvSpPr>
-          <p:cNvPr id="16" name="TextBox 15"/>
+          <p:cNvPr id="15" name="TextBox 14"/>
           <p:cNvSpPr txBox="1"/>
           <p:nvPr/>
         </p:nvSpPr>
@@ -5620,14 +5578,14 @@
                 <a:ea typeface="Georgia"/>
                 <a:cs typeface="Georgia"/>
               </a:rPr>
-              <a:t>0.183</a:t>
-            </a:r>
-          </a:p>
-        </p:txBody>
-      </p:sp>
-      <p:sp>
-        <p:nvSpPr>
-          <p:cNvPr id="17" name="TextBox 16"/>
+              <a:t>—</a:t>
+            </a:r>
+          </a:p>
+        </p:txBody>
+      </p:sp>
+      <p:sp>
+        <p:nvSpPr>
+          <p:cNvPr id="16" name="TextBox 15"/>
           <p:cNvSpPr txBox="1"/>
           <p:nvPr/>
         </p:nvSpPr>
@@ -5669,83 +5627,41 @@
       </p:sp>
       <p:sp>
         <p:nvSpPr>
-          <p:cNvPr id="18" name="TextBox 17"/>
-          <p:cNvSpPr txBox="1"/>
-          <p:nvPr/>
-        </p:nvSpPr>
-        <p:spPr>
-          <a:xfrm>
-            <a:off x="4520184" y="3337560"/>
-            <a:ext cx="3221735" cy="320040"/>
-          </a:xfrm>
-          <a:prstGeom prst="rect">
-            <a:avLst/>
-          </a:prstGeom>
-          <a:noFill/>
-        </p:spPr>
-        <p:txBody>
-          <a:bodyPr wrap="square" lIns="0" rIns="0" tIns="0" bIns="0" anchor="t"/>
-          <a:lstStyle/>
-          <a:p>
-            <a:pPr algn="l">
-              <a:spcBef>
-                <a:spcPts val="0"/>
-              </a:spcBef>
-              <a:spcAft>
-                <a:spcPts val="0"/>
-              </a:spcAft>
-            </a:pPr>
-            <a:r>
-              <a:rPr sz="1500" b="0" i="0">
-                <a:solidFill>
-                  <a:srgbClr val="1A2834"/>
+          <p:cNvPr id="17" name="TextBox 16"/>
+          <p:cNvSpPr txBox="1"/>
+          <p:nvPr/>
+        </p:nvSpPr>
+        <p:spPr>
+          <a:xfrm>
+            <a:off x="4520184" y="3794760"/>
+            <a:ext cx="3221735" cy="365760"/>
+          </a:xfrm>
+          <a:prstGeom prst="rect">
+            <a:avLst/>
+          </a:prstGeom>
+          <a:noFill/>
+        </p:spPr>
+        <p:txBody>
+          <a:bodyPr wrap="square" lIns="0" rIns="0" tIns="0" bIns="0" anchor="t"/>
+          <a:lstStyle/>
+          <a:p>
+            <a:pPr algn="l">
+              <a:spcBef>
+                <a:spcPts val="0"/>
+              </a:spcBef>
+              <a:spcAft>
+                <a:spcPts val="0"/>
+              </a:spcAft>
+            </a:pPr>
+            <a:r>
+              <a:rPr sz="1400" b="0" i="0">
+                <a:solidFill>
+                  <a:srgbClr val="5E6E7C"/>
                 </a:solidFill>
                 <a:latin typeface="Calibri"/>
                 <a:ea typeface="Calibri"/>
                 <a:cs typeface="Calibri"/>
               </a:rPr>
-              <a:t>42.6 s mean wait</a:t>
-            </a:r>
-          </a:p>
-        </p:txBody>
-      </p:sp>
-      <p:sp>
-        <p:nvSpPr>
-          <p:cNvPr id="19" name="TextBox 18"/>
-          <p:cNvSpPr txBox="1"/>
-          <p:nvPr/>
-        </p:nvSpPr>
-        <p:spPr>
-          <a:xfrm>
-            <a:off x="4520184" y="3794760"/>
-            <a:ext cx="3221735" cy="365760"/>
-          </a:xfrm>
-          <a:prstGeom prst="rect">
-            <a:avLst/>
-          </a:prstGeom>
-          <a:noFill/>
-        </p:spPr>
-        <p:txBody>
-          <a:bodyPr wrap="square" lIns="0" rIns="0" tIns="0" bIns="0" anchor="t"/>
-          <a:lstStyle/>
-          <a:p>
-            <a:pPr algn="l">
-              <a:spcBef>
-                <a:spcPts val="0"/>
-              </a:spcBef>
-              <a:spcAft>
-                <a:spcPts val="0"/>
-              </a:spcAft>
-            </a:pPr>
-            <a:r>
-              <a:rPr sz="1400" b="0" i="0">
-                <a:solidFill>
-                  <a:srgbClr val="5E6E7C"/>
-                </a:solidFill>
-                <a:latin typeface="Calibri"/>
-                <a:ea typeface="Calibri"/>
-                <a:cs typeface="Calibri"/>
-              </a:rPr>
               <a:t>The simple baseline</a:t>
             </a:r>
           </a:p>
@@ -5753,7 +5669,7 @@
       </p:sp>
       <p:sp>
         <p:nvSpPr>
-          <p:cNvPr id="20" name="Rounded Rectangle 19"/>
+          <p:cNvPr id="18" name="Rounded Rectangle 17"/>
           <p:cNvSpPr/>
           <p:nvPr/>
         </p:nvSpPr>
@@ -5800,7 +5716,7 @@
       </p:sp>
       <p:sp>
         <p:nvSpPr>
-          <p:cNvPr id="21" name="TextBox 20"/>
+          <p:cNvPr id="19" name="TextBox 18"/>
           <p:cNvSpPr txBox="1"/>
           <p:nvPr/>
         </p:nvSpPr>
@@ -5842,7 +5758,7 @@
       </p:sp>
       <p:sp>
         <p:nvSpPr>
-          <p:cNvPr id="22" name="TextBox 21"/>
+          <p:cNvPr id="20" name="TextBox 19"/>
           <p:cNvSpPr txBox="1"/>
           <p:nvPr/>
         </p:nvSpPr>
@@ -5877,14 +5793,14 @@
                 <a:ea typeface="Georgia"/>
                 <a:cs typeface="Georgia"/>
               </a:rPr>
-              <a:t>0.269</a:t>
-            </a:r>
-          </a:p>
-        </p:txBody>
-      </p:sp>
-      <p:sp>
-        <p:nvSpPr>
-          <p:cNvPr id="23" name="TextBox 22"/>
+              <a:t>—</a:t>
+            </a:r>
+          </a:p>
+        </p:txBody>
+      </p:sp>
+      <p:sp>
+        <p:nvSpPr>
+          <p:cNvPr id="21" name="TextBox 20"/>
           <p:cNvSpPr txBox="1"/>
           <p:nvPr/>
         </p:nvSpPr>
@@ -5926,83 +5842,41 @@
       </p:sp>
       <p:sp>
         <p:nvSpPr>
-          <p:cNvPr id="24" name="TextBox 23"/>
-          <p:cNvSpPr txBox="1"/>
-          <p:nvPr/>
-        </p:nvSpPr>
-        <p:spPr>
-          <a:xfrm>
-            <a:off x="8317992" y="3337560"/>
-            <a:ext cx="3221735" cy="320040"/>
-          </a:xfrm>
-          <a:prstGeom prst="rect">
-            <a:avLst/>
-          </a:prstGeom>
-          <a:noFill/>
-        </p:spPr>
-        <p:txBody>
-          <a:bodyPr wrap="square" lIns="0" rIns="0" tIns="0" bIns="0" anchor="t"/>
-          <a:lstStyle/>
-          <a:p>
-            <a:pPr algn="l">
-              <a:spcBef>
-                <a:spcPts val="0"/>
-              </a:spcBef>
-              <a:spcAft>
-                <a:spcPts val="0"/>
-              </a:spcAft>
-            </a:pPr>
-            <a:r>
-              <a:rPr sz="1500" b="0" i="0">
-                <a:solidFill>
-                  <a:srgbClr val="1A2834"/>
+          <p:cNvPr id="22" name="TextBox 21"/>
+          <p:cNvSpPr txBox="1"/>
+          <p:nvPr/>
+        </p:nvSpPr>
+        <p:spPr>
+          <a:xfrm>
+            <a:off x="8317992" y="3794760"/>
+            <a:ext cx="3221735" cy="365760"/>
+          </a:xfrm>
+          <a:prstGeom prst="rect">
+            <a:avLst/>
+          </a:prstGeom>
+          <a:noFill/>
+        </p:spPr>
+        <p:txBody>
+          <a:bodyPr wrap="square" lIns="0" rIns="0" tIns="0" bIns="0" anchor="t"/>
+          <a:lstStyle/>
+          <a:p>
+            <a:pPr algn="l">
+              <a:spcBef>
+                <a:spcPts val="0"/>
+              </a:spcBef>
+              <a:spcAft>
+                <a:spcPts val="0"/>
+              </a:spcAft>
+            </a:pPr>
+            <a:r>
+              <a:rPr sz="1400" b="0" i="0">
+                <a:solidFill>
+                  <a:srgbClr val="5E6E7C"/>
                 </a:solidFill>
                 <a:latin typeface="Calibri"/>
                 <a:ea typeface="Calibri"/>
                 <a:cs typeface="Calibri"/>
               </a:rPr>
-              <a:t>118.7 s mean wait</a:t>
-            </a:r>
-          </a:p>
-        </p:txBody>
-      </p:sp>
-      <p:sp>
-        <p:nvSpPr>
-          <p:cNvPr id="25" name="TextBox 24"/>
-          <p:cNvSpPr txBox="1"/>
-          <p:nvPr/>
-        </p:nvSpPr>
-        <p:spPr>
-          <a:xfrm>
-            <a:off x="8317992" y="3794760"/>
-            <a:ext cx="3221735" cy="365760"/>
-          </a:xfrm>
-          <a:prstGeom prst="rect">
-            <a:avLst/>
-          </a:prstGeom>
-          <a:noFill/>
-        </p:spPr>
-        <p:txBody>
-          <a:bodyPr wrap="square" lIns="0" rIns="0" tIns="0" bIns="0" anchor="t"/>
-          <a:lstStyle/>
-          <a:p>
-            <a:pPr algn="l">
-              <a:spcBef>
-                <a:spcPts val="0"/>
-              </a:spcBef>
-              <a:spcAft>
-                <a:spcPts val="0"/>
-              </a:spcAft>
-            </a:pPr>
-            <a:r>
-              <a:rPr sz="1400" b="0" i="0">
-                <a:solidFill>
-                  <a:srgbClr val="5E6E7C"/>
-                </a:solidFill>
-                <a:latin typeface="Calibri"/>
-                <a:ea typeface="Calibri"/>
-                <a:cs typeface="Calibri"/>
-              </a:rPr>
               <a:t>Higher fuel</a:t>
             </a:r>
           </a:p>
@@ -6010,7 +5884,7 @@
       </p:sp>
       <p:sp>
         <p:nvSpPr>
-          <p:cNvPr id="26" name="Rounded Rectangle 25"/>
+          <p:cNvPr id="23" name="Rounded Rectangle 22"/>
           <p:cNvSpPr/>
           <p:nvPr/>
         </p:nvSpPr>
@@ -6055,7 +5929,7 @@
       </p:sp>
       <p:sp>
         <p:nvSpPr>
-          <p:cNvPr id="27" name="TextBox 26"/>
+          <p:cNvPr id="24" name="TextBox 23"/>
           <p:cNvSpPr txBox="1"/>
           <p:nvPr/>
         </p:nvSpPr>
@@ -6097,7 +5971,7 @@
       </p:sp>
       <p:sp>
         <p:nvSpPr>
-          <p:cNvPr id="28" name="TextBox 27"/>
+          <p:cNvPr id="25" name="TextBox 24"/>
           <p:cNvSpPr txBox="1"/>
           <p:nvPr/>
         </p:nvSpPr>
@@ -6132,7 +6006,7 @@
                 <a:ea typeface="Calibri"/>
                 <a:cs typeface="Calibri"/>
               </a:rPr>
-              <a:t>A neighbor-pressure coordination term matched independent control exactly. It did not reduce fuel or waiting. A corridor needs its own design.</a:t>
+              <a:t>The coordination variant did not reduce fuel. A corridor needs its own design.</a:t>
             </a:r>
           </a:p>
         </p:txBody>
@@ -6285,7 +6159,7 @@
                 <a:ea typeface="Georgia"/>
                 <a:cs typeface="Georgia"/>
               </a:rPr>
-              <a:t>Conflicts did not rise. CO₂ still falls.</a:t>
+              <a:t>Safety: decrease. Emissions: ci overlap.</a:t>
             </a:r>
           </a:p>
         </p:txBody>
@@ -6327,7 +6201,7 @@
                 <a:ea typeface="Calibri"/>
                 <a:cs typeface="Calibri"/>
               </a:rPr>
-              <a:t>One caveat sits with those two checks: the camera model is assumed.</a:t>
+              <a:t>Both lines are the verdict fields in the loaded JSON, not a fixed sentence.</a:t>
             </a:r>
           </a:p>
         </p:txBody>
@@ -6585,7 +6459,7 @@
                 <a:ea typeface="Georgia"/>
                 <a:cs typeface="Georgia"/>
               </a:rPr>
-              <a:t>No increase</a:t>
+              <a:t>decrease</a:t>
             </a:r>
           </a:p>
         </p:txBody>
@@ -6627,7 +6501,7 @@
                 <a:ea typeface="Calibri"/>
                 <a:cs typeface="Calibri"/>
               </a:rPr>
-              <a:t>Time-to-collision conflicts from the simulator. XtraFlow minus fixed time averages 0. A model count, not a crash record.</a:t>
+              <a:t>Time-to-collision conflicts from the simulator. A model count, not a crash record.</a:t>
             </a:r>
           </a:p>
         </p:txBody>
@@ -6801,7 +6675,7 @@
                 <a:ea typeface="Georgia"/>
                 <a:cs typeface="Georgia"/>
               </a:rPr>
-              <a:t>Same direction</a:t>
+              <a:t>ci overlap</a:t>
             </a:r>
           </a:p>
         </p:txBody>
@@ -6843,7 +6717,7 @@
                 <a:ea typeface="Calibri"/>
                 <a:cs typeface="Calibri"/>
               </a:rPr>
-              <a:t>Primary model 21.1%. Alternate model 13.2%. The reduction shrinks. It does not flip.</a:t>
+              <a:t>Primary model 13.9%. Alternate model 13.7%. The reduction shrinks. It does not flip.</a:t>
             </a:r>
           </a:p>
         </p:txBody>
@@ -7427,7 +7301,7 @@
                 <a:ea typeface="Calibri"/>
                 <a:cs typeface="Calibri"/>
               </a:rPr>
-              <a:t>MEASURED ON PEAK, ONE-SIDED</a:t>
+              <a:t>MEASURED ON </a:t>
             </a:r>
           </a:p>
         </p:txBody>
@@ -7469,7 +7343,7 @@
                 <a:ea typeface="Georgia"/>
                 <a:cs typeface="Georgia"/>
               </a:rPr>
-              <a:t>0.035</a:t>
+              <a:t>0.001</a:t>
             </a:r>
             <a:r>
               <a:rPr sz="1600" b="0" i="0">
@@ -7522,7 +7396,7 @@
                 <a:ea typeface="Calibri"/>
                 <a:cs typeface="Calibri"/>
               </a:rPr>
-              <a:t>5th – 95th percentile of that mean: 0.032 – 0.038 L</a:t>
+              <a:t>5th – 95th percentile of that mean: 0.001 – 0.002 L</a:t>
             </a:r>
           </a:p>
         </p:txBody>
@@ -7620,7 +7494,7 @@
         </p:nvSpPr>
         <p:spPr>
           <a:xfrm>
-            <a:off x="2656028" y="3913632"/>
+            <a:off x="2339803" y="3913632"/>
             <a:ext cx="54864" cy="384048"/>
           </a:xfrm>
           <a:prstGeom prst="rect">
@@ -7692,7 +7566,7 @@
                 <a:ea typeface="Calibri"/>
                 <a:cs typeface="Calibri"/>
               </a:rPr>
-              <a:t>9.0 million litres</a:t>
+              <a:t>0.3 million litres</a:t>
             </a:r>
           </a:p>
         </p:txBody>
@@ -7734,7 +7608,7 @@
                 <a:ea typeface="Calibri"/>
                 <a:cs typeface="Calibri"/>
               </a:rPr>
-              <a:t>66.8 million litres</a:t>
+              <a:t>2.7 million litres</a:t>
             </a:r>
           </a:p>
         </p:txBody>
@@ -7776,7 +7650,7 @@
                 <a:ea typeface="Georgia"/>
                 <a:cs typeface="Georgia"/>
               </a:rPr>
-              <a:t>27.7 million litres</a:t>
+              <a:t>0.9 million litres</a:t>
             </a:r>
           </a:p>
         </p:txBody>
@@ -7860,7 +7734,7 @@
                 <a:ea typeface="Calibri"/>
                 <a:cs typeface="Calibri"/>
               </a:rPr>
-              <a:t>CO₂ median 67,151 tonnes   ·   21,783 tonnes – 161,618 tonnes</a:t>
+              <a:t>CO₂ median 2,296 tonnes   ·   629 tonnes – 6,640 tonnes</a:t>
             </a:r>
           </a:p>
         </p:txBody>
@@ -8993,7 +8867,7 @@
                 <a:ea typeface="Georgia"/>
                 <a:cs typeface="Georgia"/>
               </a:rPr>
-              <a:t>Redesign the corridor</a:t>
+              <a:t>Read the grid file</a:t>
             </a:r>
           </a:p>
         </p:txBody>
@@ -9035,7 +8909,7 @@
                 <a:ea typeface="Calibri"/>
                 <a:cs typeface="Calibri"/>
               </a:rPr>
-              <a:t>Neighbor pressure, as implemented, did not help the grid.</a:t>
+              <a:t>Quote a corridor result only from results/grid_results.json.</a:t>
             </a:r>
           </a:p>
         </p:txBody>
@@ -9119,7 +8993,7 @@
                 <a:ea typeface="Calibri"/>
                 <a:cs typeface="Calibri"/>
               </a:rPr>
-              <a:t>Simulation-based estimate; not a real-world deployment result</a:t>
+              <a:t>Simulation-based estimate; assumed traffic mix</a:t>
             </a:r>
           </a:p>
         </p:txBody>
@@ -10516,7 +10390,7 @@
                 <a:ea typeface="Calibri"/>
                 <a:cs typeface="Calibri"/>
               </a:rPr>
-              <a:t>Look back 150 m. Count moving vehicles at 0.50. Switch only past hysteresis 0.25. Scenario: Peak, one-sided.</a:t>
+              <a:t>Look back 150 m. Count moving vehicles at 0.50. Switch only past hysteresis 0.25. Scenario: .</a:t>
             </a:r>
           </a:p>
         </p:txBody>
@@ -13558,7 +13432,7 @@
                 <a:ea typeface="Georgia"/>
                 <a:cs typeface="Georgia"/>
               </a:rPr>
-              <a:t>Peak, one-sided</a:t>
+              <a:t>Low demand</a:t>
             </a:r>
           </a:p>
         </p:txBody>
@@ -13600,7 +13474,7 @@
                 <a:ea typeface="Calibri"/>
                 <a:cs typeface="Calibri"/>
               </a:rPr>
-              <a:t>North–south 720 veh/h. East–west 180.</a:t>
+              <a:t>150 veh/h on every approach.</a:t>
             </a:r>
           </a:p>
         </p:txBody>
@@ -13820,7 +13694,7 @@
                 <a:ea typeface="Georgia"/>
                 <a:cs typeface="Georgia"/>
               </a:rPr>
-              <a:t>Low demand</a:t>
+              <a:t>Peak, one-sided</a:t>
             </a:r>
           </a:p>
         </p:txBody>
@@ -13862,7 +13736,7 @@
                 <a:ea typeface="Calibri"/>
                 <a:cs typeface="Calibri"/>
               </a:rPr>
-              <a:t>150 veh/h on every approach.</a:t>
+              <a:t>North–south 720 veh/h. East–west 180.</a:t>
             </a:r>
           </a:p>
         </p:txBody>
@@ -14035,49 +13909,7 @@
                 <a:ea typeface="Calibri"/>
                 <a:cs typeface="Calibri"/>
               </a:rPr>
-              <a:t>Compared with Fixed time, Webster, Actuated, Max-pressure, Count only, PPO.</a:t>
-            </a:r>
-          </a:p>
-        </p:txBody>
-      </p:sp>
-      <p:sp>
-        <p:nvSpPr>
-          <p:cNvPr id="33" name="TextBox 32"/>
-          <p:cNvSpPr txBox="1"/>
-          <p:nvPr/>
-        </p:nvSpPr>
-        <p:spPr>
-          <a:xfrm>
-            <a:off x="502920" y="5669280"/>
-            <a:ext cx="11228832" cy="320040"/>
-          </a:xfrm>
-          <a:prstGeom prst="rect">
-            <a:avLst/>
-          </a:prstGeom>
-          <a:noFill/>
-        </p:spPr>
-        <p:txBody>
-          <a:bodyPr wrap="square" lIns="0" rIns="0" tIns="0" bIns="0" anchor="t"/>
-          <a:lstStyle/>
-          <a:p>
-            <a:pPr algn="l">
-              <a:spcBef>
-                <a:spcPts val="0"/>
-              </a:spcBef>
-              <a:spcAft>
-                <a:spcPts val="0"/>
-              </a:spcAft>
-            </a:pPr>
-            <a:r>
-              <a:rPr sz="1300" b="0" i="0">
-                <a:solidFill>
-                  <a:srgbClr val="5E6E7C"/>
-                </a:solidFill>
-                <a:latin typeface="Calibri"/>
-                <a:ea typeface="Calibri"/>
-                <a:cs typeface="Calibri"/>
-              </a:rPr>
-              <a:t>Built with standard lanes.</a:t>
+              <a:t>Compared with Fixed time, Webster, Actuated, Max-pressure, Count only.</a:t>
             </a:r>
           </a:p>
         </p:txBody>
@@ -14272,7 +14104,7 @@
                 <a:ea typeface="Calibri"/>
                 <a:cs typeface="Calibri"/>
               </a:rPr>
-              <a:t>Fuel per completed vehicle against fixed time. 30 paired seeds. Bootstrap 95% intervals.</a:t>
+              <a:t>Fuel per completed vehicle against fixed time. 5 paired seeds. Bootstrap 95% intervals.</a:t>
             </a:r>
           </a:p>
         </p:txBody>
@@ -14488,7 +14320,7 @@
                 <a:ea typeface="Georgia"/>
                 <a:cs typeface="Georgia"/>
               </a:rPr>
-              <a:t>Peak, one-sided</a:t>
+              <a:t>Low demand</a:t>
             </a:r>
           </a:p>
         </p:txBody>
@@ -14530,7 +14362,7 @@
                 <a:ea typeface="Georgia"/>
                 <a:cs typeface="Georgia"/>
               </a:rPr>
-              <a:t>21.8</a:t>
+              <a:t>1.9</a:t>
             </a:r>
             <a:r>
               <a:rPr sz="1800" b="1" i="0">
@@ -14583,7 +14415,7 @@
                 <a:ea typeface="Calibri"/>
                 <a:cs typeface="Calibri"/>
               </a:rPr>
-              <a:t>20.0  –  23.5</a:t>
+              <a:t>0.5  –  3.0</a:t>
             </a:r>
           </a:p>
         </p:txBody>
@@ -14885,7 +14717,7 @@
                 <a:ea typeface="Georgia"/>
                 <a:cs typeface="Georgia"/>
               </a:rPr>
-              <a:t>16.5</a:t>
+              <a:t>1.1</a:t>
             </a:r>
             <a:r>
               <a:rPr sz="1800" b="1" i="0">
@@ -14938,7 +14770,7 @@
                 <a:ea typeface="Calibri"/>
                 <a:cs typeface="Calibri"/>
               </a:rPr>
-              <a:t>15.7  –  17.3</a:t>
+              <a:t>0.6  –  1.7</a:t>
             </a:r>
           </a:p>
         </p:txBody>
@@ -15037,7 +14869,7 @@
         <p:spPr>
           <a:xfrm>
             <a:off x="3566160" y="4709160"/>
-            <a:ext cx="1712691" cy="73152"/>
+            <a:ext cx="1289076" cy="73152"/>
           </a:xfrm>
           <a:prstGeom prst="rect">
             <a:avLst/>
@@ -15198,7 +15030,7 @@
                 <a:ea typeface="Georgia"/>
                 <a:cs typeface="Georgia"/>
               </a:rPr>
-              <a:t>Low demand</a:t>
+              <a:t>Peak, one-sided</a:t>
             </a:r>
           </a:p>
         </p:txBody>
@@ -15240,7 +15072,7 @@
                 <a:ea typeface="Georgia"/>
                 <a:cs typeface="Georgia"/>
               </a:rPr>
-              <a:t>14.5</a:t>
+              <a:t>0.7</a:t>
             </a:r>
             <a:r>
               <a:rPr sz="1800" b="1" i="0">
@@ -15293,7 +15125,7 @@
                 <a:ea typeface="Calibri"/>
                 <a:cs typeface="Calibri"/>
               </a:rPr>
-              <a:t>14.0  –  14.9</a:t>
+              <a:t>-0.4  –  1.8</a:t>
             </a:r>
           </a:p>
         </p:txBody>
@@ -15392,7 +15224,7 @@
         <p:spPr>
           <a:xfrm>
             <a:off x="6409944" y="4709160"/>
-            <a:ext cx="1500707" cy="73152"/>
+            <a:ext cx="813082" cy="73152"/>
           </a:xfrm>
           <a:prstGeom prst="rect">
             <a:avLst/>
@@ -15595,7 +15427,7 @@
                 <a:ea typeface="Georgia"/>
                 <a:cs typeface="Georgia"/>
               </a:rPr>
-              <a:t>8.6</a:t>
+              <a:t>0.3</a:t>
             </a:r>
             <a:r>
               <a:rPr sz="1800" b="1" i="0">
@@ -15648,7 +15480,7 @@
                 <a:ea typeface="Calibri"/>
                 <a:cs typeface="Calibri"/>
               </a:rPr>
-              <a:t>8.2  –  9.0</a:t>
+              <a:t>-0.4  –  1.0</a:t>
             </a:r>
           </a:p>
         </p:txBody>
@@ -15747,7 +15579,7 @@
         <p:spPr>
           <a:xfrm>
             <a:off x="9253728" y="4709160"/>
-            <a:ext cx="893317" cy="73152"/>
+            <a:ext cx="348315" cy="73152"/>
           </a:xfrm>
           <a:prstGeom prst="rect">
             <a:avLst/>
@@ -16480,7 +16312,7 @@
                 <a:ea typeface="Calibri"/>
                 <a:cs typeface="Calibri"/>
               </a:rPr>
-              <a:t>Peak, one-sided</a:t>
+              <a:t>Low demand</a:t>
             </a:r>
           </a:p>
         </p:txBody>
@@ -16522,7 +16354,7 @@
                 <a:ea typeface="Georgia"/>
                 <a:cs typeface="Georgia"/>
               </a:rPr>
-              <a:t>21.8%</a:t>
+              <a:t>14.1%</a:t>
             </a:r>
           </a:p>
         </p:txBody>
@@ -16564,7 +16396,7 @@
                 <a:ea typeface="Calibri"/>
                 <a:cs typeface="Calibri"/>
               </a:rPr>
-              <a:t>20.0 – 23.5</a:t>
+              <a:t>12.7 – 15.5</a:t>
             </a:r>
           </a:p>
         </p:txBody>
@@ -16606,7 +16438,7 @@
                 <a:ea typeface="Georgia"/>
                 <a:cs typeface="Georgia"/>
               </a:rPr>
-              <a:t>9.7%</a:t>
+              <a:t>10.7%</a:t>
             </a:r>
           </a:p>
         </p:txBody>
@@ -16648,7 +16480,7 @@
                 <a:ea typeface="Calibri"/>
                 <a:cs typeface="Calibri"/>
               </a:rPr>
-              <a:t>9.4 – 10.0</a:t>
+              <a:t>9.0 – 12.4</a:t>
             </a:r>
           </a:p>
         </p:txBody>
@@ -16690,7 +16522,7 @@
                 <a:ea typeface="Georgia"/>
                 <a:cs typeface="Georgia"/>
               </a:rPr>
-              <a:t>1.2%</a:t>
+              <a:t>1.9%</a:t>
             </a:r>
           </a:p>
         </p:txBody>
@@ -16732,7 +16564,7 @@
                 <a:ea typeface="Calibri"/>
                 <a:cs typeface="Calibri"/>
               </a:rPr>
-              <a:t>0.8 – 1.5</a:t>
+              <a:t>0.5 – 3.0</a:t>
             </a:r>
           </a:p>
         </p:txBody>
@@ -16774,7 +16606,7 @@
                 <a:ea typeface="Georgia"/>
                 <a:cs typeface="Georgia"/>
               </a:rPr>
-              <a:t>1.3%</a:t>
+              <a:t>2.0%</a:t>
             </a:r>
           </a:p>
         </p:txBody>
@@ -16816,7 +16648,7 @@
                 <a:ea typeface="Calibri"/>
                 <a:cs typeface="Calibri"/>
               </a:rPr>
-              <a:t>0.9 – 1.6</a:t>
+              <a:t>0.5 – 3.3</a:t>
             </a:r>
           </a:p>
         </p:txBody>
@@ -16943,7 +16775,7 @@
                 <a:ea typeface="Georgia"/>
                 <a:cs typeface="Georgia"/>
               </a:rPr>
-              <a:t>16.5%</a:t>
+              <a:t>13.2%</a:t>
             </a:r>
           </a:p>
         </p:txBody>
@@ -16985,7 +16817,7 @@
                 <a:ea typeface="Calibri"/>
                 <a:cs typeface="Calibri"/>
               </a:rPr>
-              <a:t>15.7 – 17.3</a:t>
+              <a:t>12.3 – 14.3</a:t>
             </a:r>
           </a:p>
         </p:txBody>
@@ -17027,7 +16859,7 @@
                 <a:ea typeface="Georgia"/>
                 <a:cs typeface="Georgia"/>
               </a:rPr>
-              <a:t>8.9%</a:t>
+              <a:t>8.5%</a:t>
             </a:r>
           </a:p>
         </p:txBody>
@@ -17069,7 +16901,7 @@
                 <a:ea typeface="Calibri"/>
                 <a:cs typeface="Calibri"/>
               </a:rPr>
-              <a:t>8.5 – 9.3</a:t>
+              <a:t>7.8 – 9.2</a:t>
             </a:r>
           </a:p>
         </p:txBody>
@@ -17111,7 +16943,7 @@
                 <a:ea typeface="Georgia"/>
                 <a:cs typeface="Georgia"/>
               </a:rPr>
-              <a:t>0.6%</a:t>
+              <a:t>1.1%</a:t>
             </a:r>
           </a:p>
         </p:txBody>
@@ -17153,7 +16985,7 @@
                 <a:ea typeface="Calibri"/>
                 <a:cs typeface="Calibri"/>
               </a:rPr>
-              <a:t>0.2 – 1.0</a:t>
+              <a:t>0.6 – 1.7</a:t>
             </a:r>
           </a:p>
         </p:txBody>
@@ -17195,7 +17027,7 @@
                 <a:ea typeface="Georgia"/>
                 <a:cs typeface="Georgia"/>
               </a:rPr>
-              <a:t>0.6%</a:t>
+              <a:t>0.1%</a:t>
             </a:r>
           </a:p>
         </p:txBody>
@@ -17237,7 +17069,7 @@
                 <a:ea typeface="Calibri"/>
                 <a:cs typeface="Calibri"/>
               </a:rPr>
-              <a:t>0.3 – 1.0</a:t>
+              <a:t>-0.4 – 0.6</a:t>
             </a:r>
           </a:p>
         </p:txBody>
@@ -17322,7 +17154,7 @@
                 <a:ea typeface="Calibri"/>
                 <a:cs typeface="Calibri"/>
               </a:rPr>
-              <a:t>Low demand</a:t>
+              <a:t>Peak, one-sided</a:t>
             </a:r>
           </a:p>
         </p:txBody>
@@ -17364,7 +17196,7 @@
                 <a:ea typeface="Georgia"/>
                 <a:cs typeface="Georgia"/>
               </a:rPr>
-              <a:t>14.5%</a:t>
+              <a:t>17.5%</a:t>
             </a:r>
           </a:p>
         </p:txBody>
@@ -17406,7 +17238,7 @@
                 <a:ea typeface="Calibri"/>
                 <a:cs typeface="Calibri"/>
               </a:rPr>
-              <a:t>14.0 – 14.9</a:t>
+              <a:t>14.4 – 20.3</a:t>
             </a:r>
           </a:p>
         </p:txBody>
@@ -17448,7 +17280,7 @@
                 <a:ea typeface="Georgia"/>
                 <a:cs typeface="Georgia"/>
               </a:rPr>
-              <a:t>11.8%</a:t>
+              <a:t>8.5%</a:t>
             </a:r>
           </a:p>
         </p:txBody>
@@ -17490,7 +17322,7 @@
                 <a:ea typeface="Calibri"/>
                 <a:cs typeface="Calibri"/>
               </a:rPr>
-              <a:t>11.2 – 12.4</a:t>
+              <a:t>6.6 – 10.0</a:t>
             </a:r>
           </a:p>
         </p:txBody>
@@ -17532,7 +17364,7 @@
                 <a:ea typeface="Georgia"/>
                 <a:cs typeface="Georgia"/>
               </a:rPr>
-              <a:t>1.8%</a:t>
+              <a:t>0.7%</a:t>
             </a:r>
           </a:p>
         </p:txBody>
@@ -17574,7 +17406,7 @@
                 <a:ea typeface="Calibri"/>
                 <a:cs typeface="Calibri"/>
               </a:rPr>
-              <a:t>1.3 – 2.4</a:t>
+              <a:t>-0.4 – 1.8</a:t>
             </a:r>
           </a:p>
         </p:txBody>
@@ -17616,7 +17448,7 @@
                 <a:ea typeface="Georgia"/>
                 <a:cs typeface="Georgia"/>
               </a:rPr>
-              <a:t>2.6%</a:t>
+              <a:t>0.9%</a:t>
             </a:r>
           </a:p>
         </p:txBody>
@@ -17658,7 +17490,7 @@
                 <a:ea typeface="Calibri"/>
                 <a:cs typeface="Calibri"/>
               </a:rPr>
-              <a:t>2.1 – 3.0</a:t>
+              <a:t>-0.1 – 1.8</a:t>
             </a:r>
           </a:p>
         </p:txBody>
@@ -17785,7 +17617,7 @@
                 <a:ea typeface="Georgia"/>
                 <a:cs typeface="Georgia"/>
               </a:rPr>
-              <a:t>8.6%</a:t>
+              <a:t>7.9%</a:t>
             </a:r>
           </a:p>
         </p:txBody>
@@ -17827,7 +17659,7 @@
                 <a:ea typeface="Calibri"/>
                 <a:cs typeface="Calibri"/>
               </a:rPr>
-              <a:t>8.2 – 9.0</a:t>
+              <a:t>6.7 – 9.1</a:t>
             </a:r>
           </a:p>
         </p:txBody>
@@ -17869,7 +17701,7 @@
                 <a:ea typeface="Georgia"/>
                 <a:cs typeface="Georgia"/>
               </a:rPr>
-              <a:t>5.6%</a:t>
+              <a:t>4.8%</a:t>
             </a:r>
           </a:p>
         </p:txBody>
@@ -17911,7 +17743,7 @@
                 <a:ea typeface="Calibri"/>
                 <a:cs typeface="Calibri"/>
               </a:rPr>
-              <a:t>5.2 – 5.9</a:t>
+              <a:t>4.3 – 5.3</a:t>
             </a:r>
           </a:p>
         </p:txBody>
@@ -17953,7 +17785,7 @@
                 <a:ea typeface="Georgia"/>
                 <a:cs typeface="Georgia"/>
               </a:rPr>
-              <a:t>1.2%</a:t>
+              <a:t>0.3%</a:t>
             </a:r>
           </a:p>
         </p:txBody>
@@ -17995,7 +17827,7 @@
                 <a:ea typeface="Calibri"/>
                 <a:cs typeface="Calibri"/>
               </a:rPr>
-              <a:t>0.9 – 1.6</a:t>
+              <a:t>-0.4 – 1.0</a:t>
             </a:r>
           </a:p>
         </p:txBody>
@@ -18037,7 +17869,7 @@
                 <a:ea typeface="Georgia"/>
                 <a:cs typeface="Georgia"/>
               </a:rPr>
-              <a:t>0.6%</a:t>
+              <a:t>0.4%</a:t>
             </a:r>
           </a:p>
         </p:txBody>
@@ -18079,7 +17911,7 @@
                 <a:ea typeface="Calibri"/>
                 <a:cs typeface="Calibri"/>
               </a:rPr>
-              <a:t>0.3 – 0.9</a:t>
+              <a:t>-0.8 – 1.2</a:t>
             </a:r>
           </a:p>
         </p:txBody>
@@ -18166,7 +17998,7 @@
                 <a:ea typeface="Calibri"/>
                 <a:cs typeface="Calibri"/>
               </a:rPr>
-              <a:t>Versus max-pressure: 0.6% to 1.8%. Every 95% interval is above zero. Versus the count-only ablation: 0.6% to 2.6%. PPO used more fuel than XtraFlow in every scenario.</a:t>
+              <a:t>Versus max-pressure: 0.3% to 1.9%. Versus the count-only ablation: 0.1% to 2.0%.</a:t>
             </a:r>
           </a:p>
         </p:txBody>
@@ -18361,7 +18193,7 @@
                 <a:ea typeface="Calibri"/>
                 <a:cs typeface="Calibri"/>
               </a:rPr>
-              <a:t>Peak, one-sided, the tuning scenario, on the locked test. Completed trips match fixed time (1,796).</a:t>
+              <a:t>Low demand, the tuning scenario, on the locked test. Completed trips match fixed time (603).</a:t>
             </a:r>
           </a:p>
         </p:txBody>
@@ -18576,7 +18408,7 @@
                 <a:ea typeface="Calibri"/>
                 <a:cs typeface="Calibri"/>
               </a:rPr>
-              <a:t>0.158 L</a:t>
+              <a:t>0.136 L</a:t>
             </a:r>
           </a:p>
         </p:txBody>
@@ -18618,7 +18450,7 @@
                 <a:ea typeface="Georgia"/>
                 <a:cs typeface="Georgia"/>
               </a:rPr>
-              <a:t>0.123 L</a:t>
+              <a:t>0.117 L</a:t>
             </a:r>
           </a:p>
         </p:txBody>
@@ -18791,7 +18623,7 @@
                 <a:ea typeface="Calibri"/>
                 <a:cs typeface="Calibri"/>
               </a:rPr>
-              <a:t>41.8 s</a:t>
+              <a:t>27.2 s</a:t>
             </a:r>
           </a:p>
         </p:txBody>
@@ -18833,7 +18665,7 @@
                 <a:ea typeface="Georgia"/>
                 <a:cs typeface="Georgia"/>
               </a:rPr>
-              <a:t>18.1 s</a:t>
+              <a:t>16.2 s</a:t>
             </a:r>
           </a:p>
         </p:txBody>
@@ -19006,7 +18838,7 @@
                 <a:ea typeface="Calibri"/>
                 <a:cs typeface="Calibri"/>
               </a:rPr>
-              <a:t>19.4 veh</a:t>
+              <a:t>4.4 veh</a:t>
             </a:r>
           </a:p>
         </p:txBody>
@@ -19048,7 +18880,7 @@
                 <a:ea typeface="Georgia"/>
                 <a:cs typeface="Georgia"/>
               </a:rPr>
-              <a:t>8.8 veh</a:t>
+              <a:t>2.7 veh</a:t>
             </a:r>
           </a:p>
         </p:txBody>
@@ -19221,7 +19053,7 @@
                 <a:ea typeface="Calibri"/>
                 <a:cs typeface="Calibri"/>
               </a:rPr>
-              <a:t>710 kg</a:t>
+              <a:t>205 kg</a:t>
             </a:r>
           </a:p>
         </p:txBody>
@@ -19263,7 +19095,7 @@
                 <a:ea typeface="Georgia"/>
                 <a:cs typeface="Georgia"/>
               </a:rPr>
-              <a:t>553 kg</a:t>
+              <a:t>176 kg</a:t>
             </a:r>
           </a:p>
         </p:txBody>
@@ -19478,7 +19310,7 @@
                 <a:ea typeface="Calibri"/>
                 <a:cs typeface="Calibri"/>
               </a:rPr>
-              <a:t>35.5 s   to   19.0 s</a:t>
+              <a:t>32.2 s   to   18.8 s</a:t>
             </a:r>
           </a:p>
         </p:txBody>
@@ -19520,7 +19352,7 @@
                 <a:ea typeface="Calibri"/>
                 <a:cs typeface="Calibri"/>
               </a:rPr>
-              <a:t>46% shorter</a:t>
+              <a:t>42% shorter</a:t>
             </a:r>
           </a:p>
         </p:txBody>
@@ -19609,7 +19441,7 @@
                 <a:ea typeface="Calibri"/>
                 <a:cs typeface="Calibri"/>
               </a:rPr>
-              <a:t>Low demand</a:t>
+              <a:t>Peak, one-sided</a:t>
             </a:r>
           </a:p>
         </p:txBody>
@@ -19651,7 +19483,7 @@
                 <a:ea typeface="Calibri"/>
                 <a:cs typeface="Calibri"/>
               </a:rPr>
-              <a:t>27.3 s   to   15.9 s</a:t>
+              <a:t>37.0 s   to   18.4 s</a:t>
             </a:r>
           </a:p>
         </p:txBody>
@@ -19693,7 +19525,7 @@
                 <a:ea typeface="Calibri"/>
                 <a:cs typeface="Calibri"/>
               </a:rPr>
-              <a:t>42% shorter</a:t>
+              <a:t>50% shorter</a:t>
             </a:r>
           </a:p>
         </p:txBody>
@@ -19824,7 +19656,7 @@
                 <a:ea typeface="Calibri"/>
                 <a:cs typeface="Calibri"/>
               </a:rPr>
-              <a:t>30.1 s   to   21.9 s</a:t>
+              <a:t>30.0 s   to   21.8 s</a:t>
             </a:r>
           </a:p>
         </p:txBody>
@@ -20019,7 +19851,7 @@
                 <a:ea typeface="Georgia"/>
                 <a:cs typeface="Georgia"/>
               </a:rPr>
-              <a:t>A missed vehicle does not erase the saving</a:t>
+              <a:t>At the highest miss rate, mean fuel is under the reference lines</a:t>
             </a:r>
           </a:p>
         </p:txBody>
@@ -20061,7 +19893,7 @@
                 <a:ea typeface="Calibri"/>
                 <a:cs typeface="Calibri"/>
               </a:rPr>
-              <a:t>Peak, one-sided. 10 seeds. Vehicles are dropped from the detector at random.</a:t>
+              <a:t>Peak, one-sided. 3 seeds. Vehicles are dropped from the detector at random.</a:t>
             </a:r>
           </a:p>
         </p:txBody>
@@ -20360,7 +20192,7 @@
                 <a:ea typeface="Calibri"/>
                 <a:cs typeface="Calibri"/>
               </a:rPr>
-              <a:t>± 0.002   ·   n=10</a:t>
+              <a:t>± 0.002   ·   n=3</a:t>
             </a:r>
           </a:p>
         </p:txBody>
@@ -20575,7 +20407,7 @@
                 <a:ea typeface="Calibri"/>
                 <a:cs typeface="Calibri"/>
               </a:rPr>
-              <a:t>± 0.002   ·   n=10</a:t>
+              <a:t>± 0.002   ·   n=3</a:t>
             </a:r>
           </a:p>
         </p:txBody>
@@ -20706,7 +20538,7 @@
                 <a:ea typeface="Georgia"/>
                 <a:cs typeface="Georgia"/>
               </a:rPr>
-              <a:t>0.123</a:t>
+              <a:t>0.124</a:t>
             </a:r>
           </a:p>
         </p:txBody>
@@ -20790,7 +20622,7 @@
                 <a:ea typeface="Calibri"/>
                 <a:cs typeface="Calibri"/>
               </a:rPr>
-              <a:t>± 0.002   ·   n=10</a:t>
+              <a:t>± 0.001   ·   n=3</a:t>
             </a:r>
           </a:p>
         </p:txBody>
@@ -20921,7 +20753,7 @@
                 <a:ea typeface="Georgia"/>
                 <a:cs typeface="Georgia"/>
               </a:rPr>
-              <a:t>0.123</a:t>
+              <a:t>0.124</a:t>
             </a:r>
           </a:p>
         </p:txBody>
@@ -21005,7 +20837,7 @@
                 <a:ea typeface="Calibri"/>
                 <a:cs typeface="Calibri"/>
               </a:rPr>
-              <a:t>± 0.002   ·   n=10</a:t>
+              <a:t>± 0.001   ·   n=3</a:t>
             </a:r>
           </a:p>
         </p:txBody>
@@ -21275,120 +21107,36 @@
         </p:nvSpPr>
         <p:spPr>
           <a:xfrm>
-            <a:off x="7360920" y="4617720"/>
-            <a:ext cx="3108960" cy="411480"/>
-          </a:xfrm>
-          <a:prstGeom prst="rect">
-            <a:avLst/>
-          </a:prstGeom>
-          <a:noFill/>
-        </p:spPr>
-        <p:txBody>
-          <a:bodyPr wrap="square" lIns="0" rIns="0" tIns="0" bIns="0" anchor="t"/>
-          <a:lstStyle/>
-          <a:p>
-            <a:pPr algn="l">
-              <a:spcBef>
-                <a:spcPts val="0"/>
-              </a:spcBef>
-              <a:spcAft>
-                <a:spcPts val="0"/>
-              </a:spcAft>
-            </a:pPr>
-            <a:r>
-              <a:rPr sz="2200" b="1" i="0">
+            <a:off x="777240" y="5532120"/>
+            <a:ext cx="10680192" cy="457200"/>
+          </a:xfrm>
+          <a:prstGeom prst="rect">
+            <a:avLst/>
+          </a:prstGeom>
+          <a:noFill/>
+        </p:spPr>
+        <p:txBody>
+          <a:bodyPr wrap="square" lIns="0" rIns="0" tIns="0" bIns="0" anchor="t"/>
+          <a:lstStyle/>
+          <a:p>
+            <a:pPr algn="l">
+              <a:spcBef>
+                <a:spcPts val="0"/>
+              </a:spcBef>
+              <a:spcAft>
+                <a:spcPts val="0"/>
+              </a:spcAft>
+            </a:pPr>
+            <a:r>
+              <a:rPr sz="1400" b="0" i="0">
                 <a:solidFill>
                   <a:srgbClr val="1A2834"/>
-                </a:solidFill>
-                <a:latin typeface="Georgia"/>
-                <a:ea typeface="Georgia"/>
-                <a:cs typeface="Georgia"/>
-              </a:rPr>
-              <a:t>0.156 L</a:t>
-            </a:r>
-          </a:p>
-        </p:txBody>
-      </p:sp>
-      <p:sp>
-        <p:nvSpPr>
-          <p:cNvPr id="35" name="TextBox 34"/>
-          <p:cNvSpPr txBox="1"/>
-          <p:nvPr/>
-        </p:nvSpPr>
-        <p:spPr>
-          <a:xfrm>
-            <a:off x="7360920" y="5074920"/>
-            <a:ext cx="3108960" cy="274320"/>
-          </a:xfrm>
-          <a:prstGeom prst="rect">
-            <a:avLst/>
-          </a:prstGeom>
-          <a:noFill/>
-        </p:spPr>
-        <p:txBody>
-          <a:bodyPr wrap="square" lIns="0" rIns="0" tIns="0" bIns="0" anchor="t"/>
-          <a:lstStyle/>
-          <a:p>
-            <a:pPr algn="l">
-              <a:spcBef>
-                <a:spcPts val="0"/>
-              </a:spcBef>
-              <a:spcAft>
-                <a:spcPts val="0"/>
-              </a:spcAft>
-            </a:pPr>
-            <a:r>
-              <a:rPr sz="1300" b="0" i="0">
-                <a:solidFill>
-                  <a:srgbClr val="5E6E7C"/>
                 </a:solidFill>
                 <a:latin typeface="Calibri"/>
                 <a:ea typeface="Calibri"/>
                 <a:cs typeface="Calibri"/>
               </a:rPr>
-              <a:t>Fixed time</a:t>
-            </a:r>
-          </a:p>
-        </p:txBody>
-      </p:sp>
-      <p:sp>
-        <p:nvSpPr>
-          <p:cNvPr id="36" name="TextBox 35"/>
-          <p:cNvSpPr txBox="1"/>
-          <p:nvPr/>
-        </p:nvSpPr>
-        <p:spPr>
-          <a:xfrm>
-            <a:off x="777240" y="5532120"/>
-            <a:ext cx="10680192" cy="457200"/>
-          </a:xfrm>
-          <a:prstGeom prst="rect">
-            <a:avLst/>
-          </a:prstGeom>
-          <a:noFill/>
-        </p:spPr>
-        <p:txBody>
-          <a:bodyPr wrap="square" lIns="0" rIns="0" tIns="0" bIns="0" anchor="t"/>
-          <a:lstStyle/>
-          <a:p>
-            <a:pPr algn="l">
-              <a:spcBef>
-                <a:spcPts val="0"/>
-              </a:spcBef>
-              <a:spcAft>
-                <a:spcPts val="0"/>
-              </a:spcAft>
-            </a:pPr>
-            <a:r>
-              <a:rPr sz="1400" b="0" i="0">
-                <a:solidFill>
-                  <a:srgbClr val="1A2834"/>
-                </a:solidFill>
-                <a:latin typeface="Calibri"/>
-                <a:ea typeface="Calibri"/>
-                <a:cs typeface="Calibri"/>
-              </a:rPr>
-              <a:t>XtraFlow stays under both reference lines across this miss range. The assumed noise model at 15% miss lands at 0.124 L.</a:t>
+              <a:t>Every miss level on this slide has lower mean fuel than every reference line. Noise-model point (see noise_model.json) is 0.125 L.</a:t>
             </a:r>
           </a:p>
         </p:txBody>

</xml_diff>

<commit_message>
Tighten safety and sensitivity caveats in STATE and the deck.
Flag that raw_runs predates controller edits, soften the safety/scaling slides, and regenerate deck.pptx.
</commit_message>
<xml_diff>
--- a/results/deck.pptx
+++ b/results/deck.pptx
@@ -7430,7 +7430,7 @@
                 <a:ea typeface="Calibri"/>
                 <a:cs typeface="Calibri"/>
               </a:rPr>
-              <a:t>Fuel gain versus demand multiplier proxy</a:t>
+              <a:t>Fuel gain vs demand multiplier proxy (sensitivity data; re-run pending)</a:t>
             </a:r>
           </a:p>
         </p:txBody>
@@ -15394,7 +15394,7 @@
                 <a:ea typeface="Georgia"/>
                 <a:cs typeface="Georgia"/>
               </a:rPr>
-              <a:t>Safety: Fewer conflicts. Emissions: Intervals overlap.</a:t>
+              <a:t>Safety: mixed. Emissions: Intervals overlap.</a:t>
             </a:r>
           </a:p>
         </p:txBody>
@@ -15587,7 +15587,7 @@
             <a:avLst/>
           </a:prstGeom>
           <a:solidFill>
-            <a:srgbClr val="1B6B5A"/>
+            <a:srgbClr val="C4841D"/>
           </a:solidFill>
           <a:ln>
             <a:noFill/>
@@ -15646,7 +15646,7 @@
             <a:r>
               <a:rPr sz="1200" b="1" i="0">
                 <a:solidFill>
-                  <a:srgbClr val="1B6B5A"/>
+                  <a:srgbClr val="C4841D"/>
                 </a:solidFill>
                 <a:latin typeface="Calibri"/>
                 <a:ea typeface="Calibri"/>
@@ -15694,7 +15694,7 @@
                 <a:ea typeface="Georgia"/>
                 <a:cs typeface="Georgia"/>
               </a:rPr>
-              <a:t>Fewer conflicts</a:t>
+              <a:t>Mixed</a:t>
             </a:r>
           </a:p>
         </p:txBody>
@@ -15736,7 +15736,7 @@
                 <a:ea typeface="Calibri"/>
                 <a:cs typeface="Calibri"/>
               </a:rPr>
-              <a:t>Time-to-collision conflicts from the simulator. A model count, not a crash record.</a:t>
+              <a:t>Time-to-collision conflicts from the simulator. Verdict vs fixed only; vs max-pressure/queue-pressure the CI includes 0; vs count-only (ours_count) XtraFlow shows MORE conflicts. A model count, not a crash record.</a:t>
             </a:r>
           </a:p>
         </p:txBody>
@@ -16363,7 +16363,7 @@
                 <a:ea typeface="Calibri"/>
                 <a:cs typeface="Calibri"/>
               </a:rPr>
-              <a:t>The wide bar is the assumed city size, not uncertainty in the junction test.</a:t>
+              <a:t>Illustrative only: built from a 0.3–1.9% gap whose CIs include 0 on 2 of 4 scenarios (n=5). Not a forecast.</a:t>
             </a:r>
           </a:p>
         </p:txBody>

</xml_diff>